<commit_message>
Redesign cover without photo, refresh closing slide
</commit_message>
<xml_diff>
--- a/Difficult_Clients_Behaviors_Final.pptx
+++ b/Difficult_Clients_Behaviors_Final.pptx
@@ -929,7 +929,7 @@
           <a:lstStyle/>
           <a:p>
             <a:r>
-              <a:t>Close by running the six steps once more as a call-and-response. Takeaway: composure is the product — clients remember how you handled pressure longer than what you delivered. IMAGE CREDITS: cover abstract photo — images.unsplash.com/photo-1618005182384-a83a8bd57fbe, Unsplash License (free commercial &amp; educational use, no attribution required). Icons — Lucide (lucide.dev, github.com/lucide-icons/lucide), ISC License: crosshair, shield, flame, message-circle-warning, crown, compass, circle-check, recolored and rasterized to PNG. All other visuals are native editable PowerPoint shapes.</a:t>
+              <a:t>Close by running the six steps once more as a call-and-response. Takeaway: composure is the product — clients remember how you handled pressure longer than what you delivered. IMAGE CREDITS: Icons — Lucide (lucide.dev, github.com/lucide-icons/lucide), ISC License: crosshair, shield, flame, message-circle-warning, crown, compass, circle-check, recolored and rasterized to PNG. All other visuals are native editable PowerPoint shapes.</a:t>
             </a:r>
           </a:p>
         </p:txBody>
@@ -3952,7 +3952,7 @@
         <p:spPr>
           <a:xfrm>
             <a:off x="640080" y="502920"/>
-            <a:ext cx="6400800" cy="320040"/>
+            <a:ext cx="10881360" cy="320040"/>
           </a:xfrm>
           <a:prstGeom prst="rect">
             <a:avLst/>
@@ -3960,7 +3960,7 @@
           <a:noFill/>
         </p:spPr>
         <p:txBody>
-          <a:bodyPr wrap="square" anchor="t"/>
+          <a:bodyPr wrap="square"/>
           <a:lstStyle/>
           <a:p>
             <a:pPr algn="l">
@@ -3995,7 +3995,7 @@
         <p:spPr>
           <a:xfrm>
             <a:off x="640080" y="960120"/>
-            <a:ext cx="6766560" cy="914400"/>
+            <a:ext cx="10881360" cy="1371600"/>
           </a:xfrm>
           <a:prstGeom prst="rect">
             <a:avLst/>
@@ -4003,7 +4003,7 @@
           <a:noFill/>
         </p:spPr>
         <p:txBody>
-          <a:bodyPr wrap="square" anchor="t"/>
+          <a:bodyPr wrap="square"/>
           <a:lstStyle/>
           <a:p>
             <a:pPr algn="l">
@@ -4016,7 +4016,7 @@
               <a:spcAft>
                 <a:spcPts val="200"/>
               </a:spcAft>
-              <a:defRPr sz="3800" b="1" i="0">
+              <a:defRPr sz="4400" b="1" i="0">
                 <a:solidFill>
                   <a:srgbClr val="1A2332"/>
                 </a:solidFill>
@@ -4024,11 +4024,7 @@
               </a:defRPr>
             </a:pPr>
             <a:r>
-              <a:t>Different Types of</a:t>
-            </a:r>
-            <a:br/>
-            <a:r>
-              <a:t>Difficult Clients' Behaviors</a:t>
+              <a:t>Different Types of Difficult Clients' Behaviors</a:t>
             </a:r>
           </a:p>
         </p:txBody>
@@ -4041,8 +4037,8 @@
         </p:nvSpPr>
         <p:spPr>
           <a:xfrm>
-            <a:off x="640080" y="2788920"/>
-            <a:ext cx="6766560" cy="548640"/>
+            <a:off x="640080" y="2395728"/>
+            <a:ext cx="10881360" cy="548640"/>
           </a:xfrm>
           <a:prstGeom prst="rect">
             <a:avLst/>
@@ -4050,7 +4046,7 @@
           <a:noFill/>
         </p:spPr>
         <p:txBody>
-          <a:bodyPr wrap="square" anchor="t"/>
+          <a:bodyPr wrap="square"/>
           <a:lstStyle/>
           <a:p>
             <a:pPr algn="l">
@@ -4063,7 +4059,7 @@
               <a:spcAft>
                 <a:spcPts val="200"/>
               </a:spcAft>
-              <a:defRPr sz="1800" b="0" i="1">
+              <a:defRPr sz="2000" b="0" i="1">
                 <a:solidFill>
                   <a:srgbClr val="3D475C"/>
                 </a:solidFill>
@@ -4084,8 +4080,8 @@
         </p:nvSpPr>
         <p:spPr>
           <a:xfrm>
-            <a:off x="640080" y="3703320"/>
-            <a:ext cx="3108960" cy="502920"/>
+            <a:off x="640080" y="3154680"/>
+            <a:ext cx="3291840" cy="502920"/>
           </a:xfrm>
           <a:prstGeom prst="roundRect">
             <a:avLst>
@@ -4132,8 +4128,8 @@
         </p:nvSpPr>
         <p:spPr>
           <a:xfrm>
-            <a:off x="822960" y="3767328"/>
-            <a:ext cx="2743200" cy="411480"/>
+            <a:off x="822960" y="3218688"/>
+            <a:ext cx="2926080" cy="411480"/>
           </a:xfrm>
           <a:prstGeom prst="rect">
             <a:avLst/>
@@ -4141,7 +4137,7 @@
           <a:noFill/>
         </p:spPr>
         <p:txBody>
-          <a:bodyPr wrap="square" anchor="t"/>
+          <a:bodyPr wrap="square"/>
           <a:lstStyle/>
           <a:p>
             <a:pPr algn="l">
@@ -4175,8 +4171,8 @@
         </p:nvSpPr>
         <p:spPr>
           <a:xfrm>
-            <a:off x="3931920" y="3703320"/>
-            <a:ext cx="3108960" cy="502920"/>
+            <a:off x="4114800" y="3154680"/>
+            <a:ext cx="3291840" cy="502920"/>
           </a:xfrm>
           <a:prstGeom prst="roundRect">
             <a:avLst>
@@ -4223,8 +4219,8 @@
         </p:nvSpPr>
         <p:spPr>
           <a:xfrm>
-            <a:off x="4114800" y="3767328"/>
-            <a:ext cx="2743200" cy="411480"/>
+            <a:off x="4297680" y="3218688"/>
+            <a:ext cx="2926080" cy="411480"/>
           </a:xfrm>
           <a:prstGeom prst="rect">
             <a:avLst/>
@@ -4232,7 +4228,7 @@
           <a:noFill/>
         </p:spPr>
         <p:txBody>
-          <a:bodyPr wrap="square" anchor="t"/>
+          <a:bodyPr wrap="square"/>
           <a:lstStyle/>
           <a:p>
             <a:pPr algn="l">
@@ -4266,12 +4262,12 @@
         </p:nvSpPr>
         <p:spPr>
           <a:xfrm>
-            <a:off x="548640" y="4480560"/>
-            <a:ext cx="1444752" cy="932688"/>
+            <a:off x="566928" y="4069080"/>
+            <a:ext cx="1316736" cy="868680"/>
           </a:xfrm>
           <a:prstGeom prst="roundRect">
             <a:avLst>
-              <a:gd name="adj" fmla="val 14000"/>
+              <a:gd name="adj" fmla="val 12000"/>
             </a:avLst>
           </a:prstGeom>
           <a:solidFill>
@@ -4300,13 +4296,15 @@
           <a:bodyPr rtlCol="0" anchor="ctr"/>
           <a:lstStyle/>
           <a:p>
-            <a:pPr algn="ctr"/>
+            <a:pPr algn="ctr">
+              <a:defRPr/>
+            </a:pPr>
           </a:p>
         </p:txBody>
       </p:sp>
       <p:pic>
         <p:nvPicPr>
-          <p:cNvPr id="10" name="Picture 9" descr="crosshair.png"/>
+          <p:cNvPr id="10" name="Picture 9" descr="image.png"/>
           <p:cNvPicPr>
             <a:picLocks noChangeAspect="1"/>
           </p:cNvPicPr>
@@ -4320,8 +4318,8 @@
         </p:blipFill>
         <p:spPr>
           <a:xfrm>
-            <a:off x="1069848" y="4544568"/>
-            <a:ext cx="402336" cy="402336"/>
+            <a:off x="786384" y="4224528"/>
+            <a:ext cx="548640" cy="548640"/>
           </a:xfrm>
           <a:prstGeom prst="rect">
             <a:avLst/>
@@ -4336,8 +4334,8 @@
         </p:nvSpPr>
         <p:spPr>
           <a:xfrm>
-            <a:off x="603503" y="4956048"/>
-            <a:ext cx="1335024" cy="457200"/>
+            <a:off x="1371600" y="4133087"/>
+            <a:ext cx="1316736" cy="749808"/>
           </a:xfrm>
           <a:prstGeom prst="rect">
             <a:avLst/>
@@ -4345,10 +4343,10 @@
           <a:noFill/>
         </p:spPr>
         <p:txBody>
-          <a:bodyPr wrap="square" anchor="t" lIns="18288" rIns="18288"/>
-          <a:lstStyle/>
-          <a:p>
-            <a:pPr algn="ctr">
+          <a:bodyPr wrap="square" lIns="18288" rIns="18288"/>
+          <a:lstStyle/>
+          <a:p>
+            <a:pPr algn="l">
               <a:lnSpc>
                 <a:spcPct val="100000"/>
               </a:lnSpc>
@@ -4370,7 +4368,7 @@
             </a:r>
           </a:p>
           <a:p>
-            <a:pPr algn="ctr">
+            <a:pPr algn="l">
               <a:lnSpc>
                 <a:spcPct val="100000"/>
               </a:lnSpc>
@@ -4401,12 +4399,12 @@
         </p:nvSpPr>
         <p:spPr>
           <a:xfrm>
-            <a:off x="2043684" y="4480560"/>
-            <a:ext cx="1444752" cy="932688"/>
+            <a:off x="2779776" y="4069080"/>
+            <a:ext cx="1316736" cy="868680"/>
           </a:xfrm>
           <a:prstGeom prst="roundRect">
             <a:avLst>
-              <a:gd name="adj" fmla="val 14000"/>
+              <a:gd name="adj" fmla="val 12000"/>
             </a:avLst>
           </a:prstGeom>
           <a:solidFill>
@@ -4435,13 +4433,15 @@
           <a:bodyPr rtlCol="0" anchor="ctr"/>
           <a:lstStyle/>
           <a:p>
-            <a:pPr algn="ctr"/>
+            <a:pPr algn="ctr">
+              <a:defRPr/>
+            </a:pPr>
           </a:p>
         </p:txBody>
       </p:sp>
       <p:pic>
         <p:nvPicPr>
-          <p:cNvPr id="13" name="Picture 12" descr="shield.png"/>
+          <p:cNvPr id="13" name="Picture 12" descr="image.png"/>
           <p:cNvPicPr>
             <a:picLocks noChangeAspect="1"/>
           </p:cNvPicPr>
@@ -4455,8 +4455,8 @@
         </p:blipFill>
         <p:spPr>
           <a:xfrm>
-            <a:off x="2564891" y="4544568"/>
-            <a:ext cx="402336" cy="402336"/>
+            <a:off x="2999232" y="4224528"/>
+            <a:ext cx="548640" cy="548640"/>
           </a:xfrm>
           <a:prstGeom prst="rect">
             <a:avLst/>
@@ -4471,8 +4471,8 @@
         </p:nvSpPr>
         <p:spPr>
           <a:xfrm>
-            <a:off x="2098548" y="4956048"/>
-            <a:ext cx="1335024" cy="457200"/>
+            <a:off x="3584448" y="4133087"/>
+            <a:ext cx="1316736" cy="749808"/>
           </a:xfrm>
           <a:prstGeom prst="rect">
             <a:avLst/>
@@ -4480,10 +4480,10 @@
           <a:noFill/>
         </p:spPr>
         <p:txBody>
-          <a:bodyPr wrap="square" anchor="t" lIns="18288" rIns="18288"/>
-          <a:lstStyle/>
-          <a:p>
-            <a:pPr algn="ctr">
+          <a:bodyPr wrap="square" lIns="18288" rIns="18288"/>
+          <a:lstStyle/>
+          <a:p>
+            <a:pPr algn="l">
               <a:lnSpc>
                 <a:spcPct val="100000"/>
               </a:lnSpc>
@@ -4505,7 +4505,7 @@
             </a:r>
           </a:p>
           <a:p>
-            <a:pPr algn="ctr">
+            <a:pPr algn="l">
               <a:lnSpc>
                 <a:spcPct val="100000"/>
               </a:lnSpc>
@@ -4536,12 +4536,12 @@
         </p:nvSpPr>
         <p:spPr>
           <a:xfrm>
-            <a:off x="3538728" y="4480560"/>
-            <a:ext cx="1444752" cy="932688"/>
+            <a:off x="4992624" y="4069080"/>
+            <a:ext cx="1316736" cy="868680"/>
           </a:xfrm>
           <a:prstGeom prst="roundRect">
             <a:avLst>
-              <a:gd name="adj" fmla="val 14000"/>
+              <a:gd name="adj" fmla="val 12000"/>
             </a:avLst>
           </a:prstGeom>
           <a:solidFill>
@@ -4570,13 +4570,15 @@
           <a:bodyPr rtlCol="0" anchor="ctr"/>
           <a:lstStyle/>
           <a:p>
-            <a:pPr algn="ctr"/>
+            <a:pPr algn="ctr">
+              <a:defRPr/>
+            </a:pPr>
           </a:p>
         </p:txBody>
       </p:sp>
       <p:pic>
         <p:nvPicPr>
-          <p:cNvPr id="16" name="Picture 15" descr="flame.png"/>
+          <p:cNvPr id="16" name="Picture 15" descr="image.png"/>
           <p:cNvPicPr>
             <a:picLocks noChangeAspect="1"/>
           </p:cNvPicPr>
@@ -4590,8 +4592,8 @@
         </p:blipFill>
         <p:spPr>
           <a:xfrm>
-            <a:off x="4059936" y="4544568"/>
-            <a:ext cx="402336" cy="402336"/>
+            <a:off x="5212080" y="4224528"/>
+            <a:ext cx="548640" cy="548640"/>
           </a:xfrm>
           <a:prstGeom prst="rect">
             <a:avLst/>
@@ -4606,8 +4608,8 @@
         </p:nvSpPr>
         <p:spPr>
           <a:xfrm>
-            <a:off x="3593592" y="4956048"/>
-            <a:ext cx="1335024" cy="457200"/>
+            <a:off x="5797296" y="4133087"/>
+            <a:ext cx="1316736" cy="749808"/>
           </a:xfrm>
           <a:prstGeom prst="rect">
             <a:avLst/>
@@ -4615,10 +4617,10 @@
           <a:noFill/>
         </p:spPr>
         <p:txBody>
-          <a:bodyPr wrap="square" anchor="t" lIns="18288" rIns="18288"/>
-          <a:lstStyle/>
-          <a:p>
-            <a:pPr algn="ctr">
+          <a:bodyPr wrap="square" lIns="18288" rIns="18288"/>
+          <a:lstStyle/>
+          <a:p>
+            <a:pPr algn="l">
               <a:lnSpc>
                 <a:spcPct val="100000"/>
               </a:lnSpc>
@@ -4640,7 +4642,7 @@
             </a:r>
           </a:p>
           <a:p>
-            <a:pPr algn="ctr">
+            <a:pPr algn="l">
               <a:lnSpc>
                 <a:spcPct val="100000"/>
               </a:lnSpc>
@@ -4671,12 +4673,12 @@
         </p:nvSpPr>
         <p:spPr>
           <a:xfrm>
-            <a:off x="5033772" y="4480560"/>
-            <a:ext cx="1444752" cy="932688"/>
+            <a:off x="7205472" y="4069080"/>
+            <a:ext cx="1316736" cy="868680"/>
           </a:xfrm>
           <a:prstGeom prst="roundRect">
             <a:avLst>
-              <a:gd name="adj" fmla="val 14000"/>
+              <a:gd name="adj" fmla="val 12000"/>
             </a:avLst>
           </a:prstGeom>
           <a:solidFill>
@@ -4705,13 +4707,15 @@
           <a:bodyPr rtlCol="0" anchor="ctr"/>
           <a:lstStyle/>
           <a:p>
-            <a:pPr algn="ctr"/>
+            <a:pPr algn="ctr">
+              <a:defRPr/>
+            </a:pPr>
           </a:p>
         </p:txBody>
       </p:sp>
       <p:pic>
         <p:nvPicPr>
-          <p:cNvPr id="19" name="Picture 18" descr="message-circle-warning.png"/>
+          <p:cNvPr id="19" name="Picture 18" descr="image.png"/>
           <p:cNvPicPr>
             <a:picLocks noChangeAspect="1"/>
           </p:cNvPicPr>
@@ -4725,8 +4729,8 @@
         </p:blipFill>
         <p:spPr>
           <a:xfrm>
-            <a:off x="5554980" y="4544568"/>
-            <a:ext cx="402336" cy="402336"/>
+            <a:off x="7424927" y="4224528"/>
+            <a:ext cx="548640" cy="548640"/>
           </a:xfrm>
           <a:prstGeom prst="rect">
             <a:avLst/>
@@ -4741,8 +4745,8 @@
         </p:nvSpPr>
         <p:spPr>
           <a:xfrm>
-            <a:off x="5088636" y="4956048"/>
-            <a:ext cx="1335024" cy="457200"/>
+            <a:off x="8010144" y="4133087"/>
+            <a:ext cx="1316736" cy="749808"/>
           </a:xfrm>
           <a:prstGeom prst="rect">
             <a:avLst/>
@@ -4750,10 +4754,10 @@
           <a:noFill/>
         </p:spPr>
         <p:txBody>
-          <a:bodyPr wrap="square" anchor="t" lIns="18288" rIns="18288"/>
-          <a:lstStyle/>
-          <a:p>
-            <a:pPr algn="ctr">
+          <a:bodyPr wrap="square" lIns="18288" rIns="18288"/>
+          <a:lstStyle/>
+          <a:p>
+            <a:pPr algn="l">
               <a:lnSpc>
                 <a:spcPct val="100000"/>
               </a:lnSpc>
@@ -4775,7 +4779,7 @@
             </a:r>
           </a:p>
           <a:p>
-            <a:pPr algn="ctr">
+            <a:pPr algn="l">
               <a:lnSpc>
                 <a:spcPct val="100000"/>
               </a:lnSpc>
@@ -4806,12 +4810,12 @@
         </p:nvSpPr>
         <p:spPr>
           <a:xfrm>
-            <a:off x="6528816" y="4480560"/>
-            <a:ext cx="1444752" cy="932688"/>
+            <a:off x="9418320" y="4069080"/>
+            <a:ext cx="1316736" cy="868680"/>
           </a:xfrm>
           <a:prstGeom prst="roundRect">
             <a:avLst>
-              <a:gd name="adj" fmla="val 14000"/>
+              <a:gd name="adj" fmla="val 12000"/>
             </a:avLst>
           </a:prstGeom>
           <a:solidFill>
@@ -4840,13 +4844,15 @@
           <a:bodyPr rtlCol="0" anchor="ctr"/>
           <a:lstStyle/>
           <a:p>
-            <a:pPr algn="ctr"/>
+            <a:pPr algn="ctr">
+              <a:defRPr/>
+            </a:pPr>
           </a:p>
         </p:txBody>
       </p:sp>
       <p:pic>
         <p:nvPicPr>
-          <p:cNvPr id="22" name="Picture 21" descr="crown.png"/>
+          <p:cNvPr id="22" name="Picture 21" descr="image.png"/>
           <p:cNvPicPr>
             <a:picLocks noChangeAspect="1"/>
           </p:cNvPicPr>
@@ -4860,8 +4866,8 @@
         </p:blipFill>
         <p:spPr>
           <a:xfrm>
-            <a:off x="7050024" y="4544568"/>
-            <a:ext cx="402336" cy="402336"/>
+            <a:off x="9637776" y="4224528"/>
+            <a:ext cx="548640" cy="548640"/>
           </a:xfrm>
           <a:prstGeom prst="rect">
             <a:avLst/>
@@ -4876,8 +4882,8 @@
         </p:nvSpPr>
         <p:spPr>
           <a:xfrm>
-            <a:off x="6583679" y="4956048"/>
-            <a:ext cx="1335024" cy="457200"/>
+            <a:off x="10222992" y="4133087"/>
+            <a:ext cx="1316736" cy="749808"/>
           </a:xfrm>
           <a:prstGeom prst="rect">
             <a:avLst/>
@@ -4885,10 +4891,10 @@
           <a:noFill/>
         </p:spPr>
         <p:txBody>
-          <a:bodyPr wrap="square" anchor="t" lIns="18288" rIns="18288"/>
-          <a:lstStyle/>
-          <a:p>
-            <a:pPr algn="ctr">
+          <a:bodyPr wrap="square" lIns="18288" rIns="18288"/>
+          <a:lstStyle/>
+          <a:p>
+            <a:pPr algn="l">
               <a:lnSpc>
                 <a:spcPct val="100000"/>
               </a:lnSpc>
@@ -4910,7 +4916,7 @@
             </a:r>
           </a:p>
           <a:p>
-            <a:pPr algn="ctr">
+            <a:pPr algn="l">
               <a:lnSpc>
                 <a:spcPct val="100000"/>
               </a:lnSpc>
@@ -4941,8 +4947,8 @@
         </p:nvSpPr>
         <p:spPr>
           <a:xfrm>
-            <a:off x="640080" y="5504688"/>
-            <a:ext cx="6766560" cy="365760"/>
+            <a:off x="640080" y="5138928"/>
+            <a:ext cx="10881360" cy="365760"/>
           </a:xfrm>
           <a:prstGeom prst="rect">
             <a:avLst/>
@@ -4950,10 +4956,10 @@
           <a:noFill/>
         </p:spPr>
         <p:txBody>
-          <a:bodyPr wrap="square" anchor="t"/>
-          <a:lstStyle/>
-          <a:p>
-            <a:pPr algn="l">
+          <a:bodyPr wrap="square"/>
+          <a:lstStyle/>
+          <a:p>
+            <a:pPr algn="ctr">
               <a:lnSpc>
                 <a:spcPct val="100000"/>
               </a:lnSpc>
@@ -4963,7 +4969,7 @@
               <a:spcAft>
                 <a:spcPts val="200"/>
               </a:spcAft>
-              <a:defRPr sz="1000" b="0" i="0">
+              <a:defRPr sz="1100" b="0" i="0">
                 <a:solidFill>
                   <a:srgbClr val="3D475C"/>
                 </a:solidFill>
@@ -4976,48 +4982,24 @@
           </a:p>
         </p:txBody>
       </p:sp>
-      <p:pic>
-        <p:nvPicPr>
-          <p:cNvPr id="25" name="Picture 24" descr="cover.jpg"/>
-          <p:cNvPicPr>
-            <a:picLocks noChangeAspect="1"/>
-          </p:cNvPicPr>
-          <p:nvPr/>
-        </p:nvPicPr>
-        <p:blipFill>
-          <a:blip r:embed="rId7"/>
-          <a:stretch>
-            <a:fillRect/>
-          </a:stretch>
-        </p:blipFill>
-        <p:spPr>
-          <a:xfrm>
-            <a:off x="8028431" y="457200"/>
-            <a:ext cx="3675887" cy="5212080"/>
-          </a:xfrm>
-          <a:prstGeom prst="rect">
-            <a:avLst/>
-          </a:prstGeom>
-        </p:spPr>
-      </p:pic>
-      <p:sp>
-        <p:nvSpPr>
-          <p:cNvPr id="26" name="Rounded Rectangle 25"/>
+      <p:sp>
+        <p:nvSpPr>
+          <p:cNvPr id="25" name="Rounded Rectangle 24"/>
           <p:cNvSpPr/>
           <p:nvPr/>
         </p:nvSpPr>
         <p:spPr>
           <a:xfrm>
-            <a:off x="8028431" y="5669280"/>
-            <a:ext cx="3675887" cy="713232"/>
+            <a:off x="3721608" y="5623560"/>
+            <a:ext cx="4754880" cy="621792"/>
           </a:xfrm>
           <a:prstGeom prst="roundRect">
             <a:avLst>
-              <a:gd name="adj" fmla="val 12000"/>
+              <a:gd name="adj" fmla="val 50000"/>
             </a:avLst>
           </a:prstGeom>
           <a:solidFill>
-            <a:srgbClr val="1A2332"/>
+            <a:srgbClr val="0F766E"/>
           </a:solidFill>
           <a:ln>
             <a:noFill/>
@@ -5048,14 +5030,14 @@
       </p:sp>
       <p:sp>
         <p:nvSpPr>
-          <p:cNvPr id="27" name="TextBox 26"/>
+          <p:cNvPr id="26" name="TextBox 25"/>
           <p:cNvSpPr txBox="1"/>
           <p:nvPr/>
         </p:nvSpPr>
         <p:spPr>
           <a:xfrm>
-            <a:off x="8257031" y="5760720"/>
-            <a:ext cx="3246120" cy="548640"/>
+            <a:off x="3721608" y="5669280"/>
+            <a:ext cx="4754880" cy="530352"/>
           </a:xfrm>
           <a:prstGeom prst="rect">
             <a:avLst/>
@@ -5063,10 +5045,10 @@
           <a:noFill/>
         </p:spPr>
         <p:txBody>
-          <a:bodyPr wrap="square" anchor="t"/>
-          <a:lstStyle/>
-          <a:p>
-            <a:pPr algn="l">
+          <a:bodyPr wrap="square"/>
+          <a:lstStyle/>
+          <a:p>
+            <a:pPr algn="ctr">
               <a:lnSpc>
                 <a:spcPct val="100000"/>
               </a:lnSpc>
@@ -5085,49 +5067,6 @@
             </a:pPr>
             <a:r>
               <a:t>Stay calm. Read the behavior. Match the response.</a:t>
-            </a:r>
-          </a:p>
-        </p:txBody>
-      </p:sp>
-      <p:sp>
-        <p:nvSpPr>
-          <p:cNvPr id="28" name="TextBox 27"/>
-          <p:cNvSpPr txBox="1"/>
-          <p:nvPr/>
-        </p:nvSpPr>
-        <p:spPr>
-          <a:xfrm>
-            <a:off x="640080" y="6355080"/>
-            <a:ext cx="10972800" cy="274320"/>
-          </a:xfrm>
-          <a:prstGeom prst="rect">
-            <a:avLst/>
-          </a:prstGeom>
-          <a:noFill/>
-        </p:spPr>
-        <p:txBody>
-          <a:bodyPr wrap="square" anchor="t"/>
-          <a:lstStyle/>
-          <a:p>
-            <a:pPr algn="l">
-              <a:lnSpc>
-                <a:spcPct val="100000"/>
-              </a:lnSpc>
-              <a:spcBef>
-                <a:spcPts val="0"/>
-              </a:spcBef>
-              <a:spcAft>
-                <a:spcPts val="200"/>
-              </a:spcAft>
-              <a:defRPr sz="1000" b="0" i="0">
-                <a:solidFill>
-                  <a:srgbClr val="3D475C"/>
-                </a:solidFill>
-                <a:latin typeface="Calibri"/>
-              </a:defRPr>
-            </a:pPr>
-            <a:r>
-              <a:t>8 slides  ·  editable  ·  Unsplash photo, Lucide icons (see slide 8 notes)</a:t>
             </a:r>
           </a:p>
         </p:txBody>
@@ -13070,7 +13009,7 @@
           <a:noFill/>
         </p:spPr>
         <p:txBody>
-          <a:bodyPr wrap="square" anchor="t"/>
+          <a:bodyPr wrap="square"/>
           <a:lstStyle/>
           <a:p>
             <a:pPr algn="l">
@@ -13104,8 +13043,8 @@
         </p:nvSpPr>
         <p:spPr>
           <a:xfrm>
-            <a:off x="548640" y="777240"/>
-            <a:ext cx="11091672" cy="1005840"/>
+            <a:off x="548640" y="914400"/>
+            <a:ext cx="6400800" cy="1554480"/>
           </a:xfrm>
           <a:prstGeom prst="rect">
             <a:avLst/>
@@ -13113,10 +13052,10 @@
           <a:noFill/>
         </p:spPr>
         <p:txBody>
-          <a:bodyPr wrap="square" anchor="ctr"/>
-          <a:lstStyle/>
-          <a:p>
-            <a:pPr algn="ctr">
+          <a:bodyPr wrap="square"/>
+          <a:lstStyle/>
+          <a:p>
+            <a:pPr algn="l">
               <a:lnSpc>
                 <a:spcPct val="100000"/>
               </a:lnSpc>
@@ -13126,7 +13065,7 @@
               <a:spcAft>
                 <a:spcPts val="200"/>
               </a:spcAft>
-              <a:defRPr sz="3000" b="1" i="0">
+              <a:defRPr sz="2800" b="1" i="0">
                 <a:solidFill>
                   <a:srgbClr val="1A2332"/>
                 </a:solidFill>
@@ -13134,25 +13073,171 @@
               </a:defRPr>
             </a:pPr>
             <a:r>
-              <a:t>“Stay calm, professional, and solution-focused</a:t>
-            </a:r>
-            <a:br/>
-            <a:r>
-              <a:t>with every type of client.”</a:t>
-            </a:r>
-          </a:p>
-        </p:txBody>
-      </p:sp>
-      <p:sp>
-        <p:nvSpPr>
-          <p:cNvPr id="4" name="Rounded Rectangle 3"/>
+              <a:t>“Stay calm, professional, and solution-focused with every type of client.”</a:t>
+            </a:r>
+          </a:p>
+        </p:txBody>
+      </p:sp>
+      <p:sp>
+        <p:nvSpPr>
+          <p:cNvPr id="4" name="TextBox 3"/>
+          <p:cNvSpPr txBox="1"/>
+          <p:nvPr/>
+        </p:nvSpPr>
+        <p:spPr>
+          <a:xfrm>
+            <a:off x="548640" y="2697480"/>
+            <a:ext cx="6400800" cy="1005840"/>
+          </a:xfrm>
+          <a:prstGeom prst="rect">
+            <a:avLst/>
+          </a:prstGeom>
+          <a:noFill/>
+        </p:spPr>
+        <p:txBody>
+          <a:bodyPr wrap="square"/>
+          <a:lstStyle/>
+          <a:p>
+            <a:pPr algn="l">
+              <a:lnSpc>
+                <a:spcPct val="100000"/>
+              </a:lnSpc>
+              <a:spcBef>
+                <a:spcPts val="0"/>
+              </a:spcBef>
+              <a:spcAft>
+                <a:spcPts val="200"/>
+              </a:spcAft>
+              <a:defRPr sz="2000" b="0" i="1">
+                <a:solidFill>
+                  <a:srgbClr val="0B5B55"/>
+                </a:solidFill>
+                <a:latin typeface="Calibri"/>
+              </a:defRPr>
+            </a:pPr>
+            <a:r>
+              <a:t>You can’t control the client’s temperature —</a:t>
+            </a:r>
+          </a:p>
+          <a:p>
+            <a:pPr algn="l">
+              <a:lnSpc>
+                <a:spcPct val="100000"/>
+              </a:lnSpc>
+              <a:spcBef>
+                <a:spcPts val="0"/>
+              </a:spcBef>
+              <a:spcAft>
+                <a:spcPts val="200"/>
+              </a:spcAft>
+              <a:defRPr sz="2000" b="0" i="1">
+                <a:solidFill>
+                  <a:srgbClr val="0B5B55"/>
+                </a:solidFill>
+                <a:latin typeface="Calibri"/>
+              </a:defRPr>
+            </a:pPr>
+            <a:r>
+              <a:t>but you always control your own.</a:t>
+            </a:r>
+          </a:p>
+        </p:txBody>
+      </p:sp>
+      <p:sp>
+        <p:nvSpPr>
+          <p:cNvPr id="5" name="TextBox 4"/>
+          <p:cNvSpPr txBox="1"/>
+          <p:nvPr/>
+        </p:nvSpPr>
+        <p:spPr>
+          <a:xfrm>
+            <a:off x="548640" y="3977639"/>
+            <a:ext cx="6400800" cy="457200"/>
+          </a:xfrm>
+          <a:prstGeom prst="rect">
+            <a:avLst/>
+          </a:prstGeom>
+          <a:noFill/>
+        </p:spPr>
+        <p:txBody>
+          <a:bodyPr wrap="square"/>
+          <a:lstStyle/>
+          <a:p>
+            <a:pPr algn="l">
+              <a:lnSpc>
+                <a:spcPct val="100000"/>
+              </a:lnSpc>
+              <a:spcBef>
+                <a:spcPts val="0"/>
+              </a:spcBef>
+              <a:spcAft>
+                <a:spcPts val="200"/>
+              </a:spcAft>
+              <a:defRPr sz="1100" b="0" i="0">
+                <a:solidFill>
+                  <a:srgbClr val="3D475C"/>
+                </a:solidFill>
+                <a:latin typeface="Calibri"/>
+              </a:defRPr>
+            </a:pPr>
+            <a:r>
+              <a:rPr sz="1100" b="1">
+                <a:solidFill>
+                  <a:srgbClr val="3D475C"/>
+                </a:solidFill>
+                <a:latin typeface="Calibri"/>
+              </a:rPr>
+              <a:t>01 Clarify  ·  </a:t>
+            </a:r>
+            <a:r>
+              <a:rPr sz="1100" b="1">
+                <a:solidFill>
+                  <a:srgbClr val="3D475C"/>
+                </a:solidFill>
+                <a:latin typeface="Calibri"/>
+              </a:rPr>
+              <a:t>02 Empathize  ·  </a:t>
+            </a:r>
+            <a:r>
+              <a:rPr sz="1100" b="1">
+                <a:solidFill>
+                  <a:srgbClr val="3D475C"/>
+                </a:solidFill>
+                <a:latin typeface="Calibri"/>
+              </a:rPr>
+              <a:t>03 Bound  ·  </a:t>
+            </a:r>
+            <a:r>
+              <a:rPr sz="1100" b="1">
+                <a:solidFill>
+                  <a:srgbClr val="3D475C"/>
+                </a:solidFill>
+                <a:latin typeface="Calibri"/>
+              </a:rPr>
+              <a:t>04 Diagnose  ·  </a:t>
+            </a:r>
+            <a:r>
+              <a:rPr sz="1100" b="1">
+                <a:solidFill>
+                  <a:srgbClr val="3D475C"/>
+                </a:solidFill>
+                <a:latin typeface="Calibri"/>
+              </a:rPr>
+              <a:t>05 Evidence</a:t>
+            </a:r>
+          </a:p>
+        </p:txBody>
+      </p:sp>
+      <p:sp>
+        <p:nvSpPr>
+          <p:cNvPr id="6" name="Rounded Rectangle 5"/>
           <p:cNvSpPr/>
           <p:nvPr/>
         </p:nvSpPr>
         <p:spPr>
           <a:xfrm>
-            <a:off x="822960" y="2514600"/>
-            <a:ext cx="1572768" cy="658368"/>
+            <a:off x="548640" y="4709160"/>
+            <a:ext cx="2377440" cy="566928"/>
           </a:xfrm>
           <a:prstGeom prst="roundRect">
             <a:avLst>
@@ -13191,14 +13276,14 @@
       </p:sp>
       <p:sp>
         <p:nvSpPr>
-          <p:cNvPr id="5" name="TextBox 4"/>
+          <p:cNvPr id="7" name="TextBox 6"/>
           <p:cNvSpPr txBox="1"/>
           <p:nvPr/>
         </p:nvSpPr>
         <p:spPr>
           <a:xfrm>
-            <a:off x="822960" y="2578608"/>
-            <a:ext cx="1572768" cy="530352"/>
+            <a:off x="548640" y="4754880"/>
+            <a:ext cx="2377440" cy="475488"/>
           </a:xfrm>
           <a:prstGeom prst="rect">
             <a:avLst/>
@@ -13206,7 +13291,7 @@
           <a:noFill/>
         </p:spPr>
         <p:txBody>
-          <a:bodyPr wrap="square" anchor="t"/>
+          <a:bodyPr wrap="square"/>
           <a:lstStyle/>
           <a:p>
             <a:pPr algn="ctr">
@@ -13219,7 +13304,7 @@
               <a:spcAft>
                 <a:spcPts val="200"/>
               </a:spcAft>
-              <a:defRPr sz="1000" b="1" i="0">
+              <a:defRPr sz="1300" b="1" i="0">
                 <a:solidFill>
                   <a:srgbClr val="FFFFFF"/>
                 </a:solidFill>
@@ -13227,6 +13312,138 @@
               </a:defRPr>
             </a:pPr>
             <a:r>
+              <a:t>Thank you  ·  Q&amp;A</a:t>
+            </a:r>
+          </a:p>
+        </p:txBody>
+      </p:sp>
+      <p:sp>
+        <p:nvSpPr>
+          <p:cNvPr id="8" name="TextBox 7"/>
+          <p:cNvSpPr txBox="1"/>
+          <p:nvPr/>
+        </p:nvSpPr>
+        <p:spPr>
+          <a:xfrm>
+            <a:off x="7589520" y="914400"/>
+            <a:ext cx="4023360" cy="320040"/>
+          </a:xfrm>
+          <a:prstGeom prst="rect">
+            <a:avLst/>
+          </a:prstGeom>
+          <a:noFill/>
+        </p:spPr>
+        <p:txBody>
+          <a:bodyPr wrap="square"/>
+          <a:lstStyle/>
+          <a:p>
+            <a:pPr algn="l">
+              <a:lnSpc>
+                <a:spcPct val="100000"/>
+              </a:lnSpc>
+              <a:spcBef>
+                <a:spcPts val="0"/>
+              </a:spcBef>
+              <a:spcAft>
+                <a:spcPts val="200"/>
+              </a:spcAft>
+              <a:defRPr sz="1100" b="1" i="0">
+                <a:solidFill>
+                  <a:srgbClr val="0B5B55"/>
+                </a:solidFill>
+                <a:latin typeface="Calibri"/>
+              </a:defRPr>
+            </a:pPr>
+            <a:r>
+              <a:t>THE SEQUENCE — YOUR 6 MOVES</a:t>
+            </a:r>
+          </a:p>
+        </p:txBody>
+      </p:sp>
+      <p:sp>
+        <p:nvSpPr>
+          <p:cNvPr id="9" name="Rounded Rectangle 8"/>
+          <p:cNvSpPr/>
+          <p:nvPr/>
+        </p:nvSpPr>
+        <p:spPr>
+          <a:xfrm>
+            <a:off x="7589520" y="1417320"/>
+            <a:ext cx="4023360" cy="566928"/>
+          </a:xfrm>
+          <a:prstGeom prst="roundRect">
+            <a:avLst>
+              <a:gd name="adj" fmla="val 50000"/>
+            </a:avLst>
+          </a:prstGeom>
+          <a:solidFill>
+            <a:srgbClr val="0F766E"/>
+          </a:solidFill>
+          <a:ln>
+            <a:noFill/>
+          </a:ln>
+          <a:effectLst/>
+        </p:spPr>
+        <p:style>
+          <a:lnRef idx="1">
+            <a:schemeClr val="accent1"/>
+          </a:lnRef>
+          <a:fillRef idx="3">
+            <a:schemeClr val="accent1"/>
+          </a:fillRef>
+          <a:effectRef idx="2">
+            <a:schemeClr val="accent1"/>
+          </a:effectRef>
+          <a:fontRef idx="minor">
+            <a:schemeClr val="lt1"/>
+          </a:fontRef>
+        </p:style>
+        <p:txBody>
+          <a:bodyPr rtlCol="0" anchor="ctr"/>
+          <a:lstStyle/>
+          <a:p>
+            <a:pPr algn="ctr"/>
+          </a:p>
+        </p:txBody>
+      </p:sp>
+      <p:sp>
+        <p:nvSpPr>
+          <p:cNvPr id="10" name="TextBox 9"/>
+          <p:cNvSpPr txBox="1"/>
+          <p:nvPr/>
+        </p:nvSpPr>
+        <p:spPr>
+          <a:xfrm>
+            <a:off x="7589520" y="1463040"/>
+            <a:ext cx="4023360" cy="475488"/>
+          </a:xfrm>
+          <a:prstGeom prst="rect">
+            <a:avLst/>
+          </a:prstGeom>
+          <a:noFill/>
+        </p:spPr>
+        <p:txBody>
+          <a:bodyPr wrap="square" lIns="274320"/>
+          <a:lstStyle/>
+          <a:p>
+            <a:pPr algn="l">
+              <a:lnSpc>
+                <a:spcPct val="100000"/>
+              </a:lnSpc>
+              <a:spcBef>
+                <a:spcPts val="0"/>
+              </a:spcBef>
+              <a:spcAft>
+                <a:spcPts val="200"/>
+              </a:spcAft>
+              <a:defRPr sz="1200" b="1" i="0">
+                <a:solidFill>
+                  <a:srgbClr val="FFFFFF"/>
+                </a:solidFill>
+                <a:latin typeface="Calibri"/>
+              </a:defRPr>
+            </a:pPr>
+            <a:r>
               <a:t>1. Listen</a:t>
             </a:r>
           </a:p>
@@ -13234,57 +13451,14 @@
       </p:sp>
       <p:sp>
         <p:nvSpPr>
-          <p:cNvPr id="6" name="TextBox 5"/>
-          <p:cNvSpPr txBox="1"/>
-          <p:nvPr/>
-        </p:nvSpPr>
-        <p:spPr>
-          <a:xfrm>
-            <a:off x="2404872" y="2578608"/>
-            <a:ext cx="219456" cy="530352"/>
-          </a:xfrm>
-          <a:prstGeom prst="rect">
-            <a:avLst/>
-          </a:prstGeom>
-          <a:noFill/>
-        </p:spPr>
-        <p:txBody>
-          <a:bodyPr wrap="square" anchor="t"/>
-          <a:lstStyle/>
-          <a:p>
-            <a:pPr algn="ctr">
-              <a:lnSpc>
-                <a:spcPct val="100000"/>
-              </a:lnSpc>
-              <a:spcBef>
-                <a:spcPts val="0"/>
-              </a:spcBef>
-              <a:spcAft>
-                <a:spcPts val="200"/>
-              </a:spcAft>
-              <a:defRPr sz="2000" b="1" i="0">
-                <a:solidFill>
-                  <a:srgbClr val="0B5B55"/>
-                </a:solidFill>
-                <a:latin typeface="Calibri"/>
-              </a:defRPr>
-            </a:pPr>
-            <a:r>
-              <a:t>›</a:t>
-            </a:r>
-          </a:p>
-        </p:txBody>
-      </p:sp>
-      <p:sp>
-        <p:nvSpPr>
-          <p:cNvPr id="7" name="Rounded Rectangle 6"/>
+          <p:cNvPr id="11" name="Rounded Rectangle 10"/>
           <p:cNvSpPr/>
           <p:nvPr/>
         </p:nvSpPr>
         <p:spPr>
           <a:xfrm>
-            <a:off x="2624328" y="2514600"/>
-            <a:ext cx="1572768" cy="658368"/>
+            <a:off x="7589520" y="2112264"/>
+            <a:ext cx="4023360" cy="566928"/>
           </a:xfrm>
           <a:prstGeom prst="roundRect">
             <a:avLst>
@@ -13323,14 +13497,14 @@
       </p:sp>
       <p:sp>
         <p:nvSpPr>
-          <p:cNvPr id="8" name="TextBox 7"/>
+          <p:cNvPr id="12" name="TextBox 11"/>
           <p:cNvSpPr txBox="1"/>
           <p:nvPr/>
         </p:nvSpPr>
         <p:spPr>
           <a:xfrm>
-            <a:off x="2624328" y="2578608"/>
-            <a:ext cx="1572768" cy="530352"/>
+            <a:off x="7589520" y="2157984"/>
+            <a:ext cx="4023360" cy="475488"/>
           </a:xfrm>
           <a:prstGeom prst="rect">
             <a:avLst/>
@@ -13338,10 +13512,10 @@
           <a:noFill/>
         </p:spPr>
         <p:txBody>
-          <a:bodyPr wrap="square" anchor="t"/>
-          <a:lstStyle/>
-          <a:p>
-            <a:pPr algn="ctr">
+          <a:bodyPr wrap="square" lIns="274320"/>
+          <a:lstStyle/>
+          <a:p>
+            <a:pPr algn="l">
               <a:lnSpc>
                 <a:spcPct val="100000"/>
               </a:lnSpc>
@@ -13351,7 +13525,7 @@
               <a:spcAft>
                 <a:spcPts val="200"/>
               </a:spcAft>
-              <a:defRPr sz="1000" b="1" i="0">
+              <a:defRPr sz="1200" b="1" i="0">
                 <a:solidFill>
                   <a:srgbClr val="FFFFFF"/>
                 </a:solidFill>
@@ -13366,57 +13540,14 @@
       </p:sp>
       <p:sp>
         <p:nvSpPr>
-          <p:cNvPr id="9" name="TextBox 8"/>
-          <p:cNvSpPr txBox="1"/>
-          <p:nvPr/>
-        </p:nvSpPr>
-        <p:spPr>
-          <a:xfrm>
-            <a:off x="4206240" y="2578608"/>
-            <a:ext cx="219456" cy="530352"/>
-          </a:xfrm>
-          <a:prstGeom prst="rect">
-            <a:avLst/>
-          </a:prstGeom>
-          <a:noFill/>
-        </p:spPr>
-        <p:txBody>
-          <a:bodyPr wrap="square" anchor="t"/>
-          <a:lstStyle/>
-          <a:p>
-            <a:pPr algn="ctr">
-              <a:lnSpc>
-                <a:spcPct val="100000"/>
-              </a:lnSpc>
-              <a:spcBef>
-                <a:spcPts val="0"/>
-              </a:spcBef>
-              <a:spcAft>
-                <a:spcPts val="200"/>
-              </a:spcAft>
-              <a:defRPr sz="2000" b="1" i="0">
-                <a:solidFill>
-                  <a:srgbClr val="0B5B55"/>
-                </a:solidFill>
-                <a:latin typeface="Calibri"/>
-              </a:defRPr>
-            </a:pPr>
-            <a:r>
-              <a:t>›</a:t>
-            </a:r>
-          </a:p>
-        </p:txBody>
-      </p:sp>
-      <p:sp>
-        <p:nvSpPr>
-          <p:cNvPr id="10" name="Rounded Rectangle 9"/>
+          <p:cNvPr id="13" name="Rounded Rectangle 12"/>
           <p:cNvSpPr/>
           <p:nvPr/>
         </p:nvSpPr>
         <p:spPr>
           <a:xfrm>
-            <a:off x="4425696" y="2514600"/>
-            <a:ext cx="1572768" cy="658368"/>
+            <a:off x="7589520" y="2807208"/>
+            <a:ext cx="4023360" cy="566928"/>
           </a:xfrm>
           <a:prstGeom prst="roundRect">
             <a:avLst>
@@ -13455,14 +13586,14 @@
       </p:sp>
       <p:sp>
         <p:nvSpPr>
-          <p:cNvPr id="11" name="TextBox 10"/>
+          <p:cNvPr id="14" name="TextBox 13"/>
           <p:cNvSpPr txBox="1"/>
           <p:nvPr/>
         </p:nvSpPr>
         <p:spPr>
           <a:xfrm>
-            <a:off x="4425696" y="2578608"/>
-            <a:ext cx="1572768" cy="530352"/>
+            <a:off x="7589520" y="2852928"/>
+            <a:ext cx="4023360" cy="475488"/>
           </a:xfrm>
           <a:prstGeom prst="rect">
             <a:avLst/>
@@ -13470,10 +13601,10 @@
           <a:noFill/>
         </p:spPr>
         <p:txBody>
-          <a:bodyPr wrap="square" anchor="t"/>
-          <a:lstStyle/>
-          <a:p>
-            <a:pPr algn="ctr">
+          <a:bodyPr wrap="square" lIns="274320"/>
+          <a:lstStyle/>
+          <a:p>
+            <a:pPr algn="l">
               <a:lnSpc>
                 <a:spcPct val="100000"/>
               </a:lnSpc>
@@ -13483,7 +13614,7 @@
               <a:spcAft>
                 <a:spcPts val="200"/>
               </a:spcAft>
-              <a:defRPr sz="1000" b="1" i="0">
+              <a:defRPr sz="1200" b="1" i="0">
                 <a:solidFill>
                   <a:srgbClr val="FFFFFF"/>
                 </a:solidFill>
@@ -13498,57 +13629,14 @@
       </p:sp>
       <p:sp>
         <p:nvSpPr>
-          <p:cNvPr id="12" name="TextBox 11"/>
-          <p:cNvSpPr txBox="1"/>
-          <p:nvPr/>
-        </p:nvSpPr>
-        <p:spPr>
-          <a:xfrm>
-            <a:off x="6007608" y="2578608"/>
-            <a:ext cx="219456" cy="530352"/>
-          </a:xfrm>
-          <a:prstGeom prst="rect">
-            <a:avLst/>
-          </a:prstGeom>
-          <a:noFill/>
-        </p:spPr>
-        <p:txBody>
-          <a:bodyPr wrap="square" anchor="t"/>
-          <a:lstStyle/>
-          <a:p>
-            <a:pPr algn="ctr">
-              <a:lnSpc>
-                <a:spcPct val="100000"/>
-              </a:lnSpc>
-              <a:spcBef>
-                <a:spcPts val="0"/>
-              </a:spcBef>
-              <a:spcAft>
-                <a:spcPts val="200"/>
-              </a:spcAft>
-              <a:defRPr sz="2000" b="1" i="0">
-                <a:solidFill>
-                  <a:srgbClr val="0B5B55"/>
-                </a:solidFill>
-                <a:latin typeface="Calibri"/>
-              </a:defRPr>
-            </a:pPr>
-            <a:r>
-              <a:t>›</a:t>
-            </a:r>
-          </a:p>
-        </p:txBody>
-      </p:sp>
-      <p:sp>
-        <p:nvSpPr>
-          <p:cNvPr id="13" name="Rounded Rectangle 12"/>
+          <p:cNvPr id="15" name="Rounded Rectangle 14"/>
           <p:cNvSpPr/>
           <p:nvPr/>
         </p:nvSpPr>
         <p:spPr>
           <a:xfrm>
-            <a:off x="6227064" y="2514600"/>
-            <a:ext cx="1572768" cy="658368"/>
+            <a:off x="7589520" y="3502152"/>
+            <a:ext cx="4023360" cy="566928"/>
           </a:xfrm>
           <a:prstGeom prst="roundRect">
             <a:avLst>
@@ -13587,14 +13675,14 @@
       </p:sp>
       <p:sp>
         <p:nvSpPr>
-          <p:cNvPr id="14" name="TextBox 13"/>
+          <p:cNvPr id="16" name="TextBox 15"/>
           <p:cNvSpPr txBox="1"/>
           <p:nvPr/>
         </p:nvSpPr>
         <p:spPr>
           <a:xfrm>
-            <a:off x="6227064" y="2578608"/>
-            <a:ext cx="1572768" cy="530352"/>
+            <a:off x="7589520" y="3547872"/>
+            <a:ext cx="4023360" cy="475488"/>
           </a:xfrm>
           <a:prstGeom prst="rect">
             <a:avLst/>
@@ -13602,10 +13690,10 @@
           <a:noFill/>
         </p:spPr>
         <p:txBody>
-          <a:bodyPr wrap="square" anchor="t"/>
-          <a:lstStyle/>
-          <a:p>
-            <a:pPr algn="ctr">
+          <a:bodyPr wrap="square" lIns="274320"/>
+          <a:lstStyle/>
+          <a:p>
+            <a:pPr algn="l">
               <a:lnSpc>
                 <a:spcPct val="100000"/>
               </a:lnSpc>
@@ -13615,7 +13703,7 @@
               <a:spcAft>
                 <a:spcPts val="200"/>
               </a:spcAft>
-              <a:defRPr sz="1000" b="1" i="0">
+              <a:defRPr sz="1200" b="1" i="0">
                 <a:solidFill>
                   <a:srgbClr val="FFFFFF"/>
                 </a:solidFill>
@@ -13630,57 +13718,14 @@
       </p:sp>
       <p:sp>
         <p:nvSpPr>
-          <p:cNvPr id="15" name="TextBox 14"/>
-          <p:cNvSpPr txBox="1"/>
-          <p:nvPr/>
-        </p:nvSpPr>
-        <p:spPr>
-          <a:xfrm>
-            <a:off x="7808975" y="2578608"/>
-            <a:ext cx="219456" cy="530352"/>
-          </a:xfrm>
-          <a:prstGeom prst="rect">
-            <a:avLst/>
-          </a:prstGeom>
-          <a:noFill/>
-        </p:spPr>
-        <p:txBody>
-          <a:bodyPr wrap="square" anchor="t"/>
-          <a:lstStyle/>
-          <a:p>
-            <a:pPr algn="ctr">
-              <a:lnSpc>
-                <a:spcPct val="100000"/>
-              </a:lnSpc>
-              <a:spcBef>
-                <a:spcPts val="0"/>
-              </a:spcBef>
-              <a:spcAft>
-                <a:spcPts val="200"/>
-              </a:spcAft>
-              <a:defRPr sz="2000" b="1" i="0">
-                <a:solidFill>
-                  <a:srgbClr val="0B5B55"/>
-                </a:solidFill>
-                <a:latin typeface="Calibri"/>
-              </a:defRPr>
-            </a:pPr>
-            <a:r>
-              <a:t>›</a:t>
-            </a:r>
-          </a:p>
-        </p:txBody>
-      </p:sp>
-      <p:sp>
-        <p:nvSpPr>
-          <p:cNvPr id="16" name="Rounded Rectangle 15"/>
+          <p:cNvPr id="17" name="Rounded Rectangle 16"/>
           <p:cNvSpPr/>
           <p:nvPr/>
         </p:nvSpPr>
         <p:spPr>
           <a:xfrm>
-            <a:off x="8028431" y="2514600"/>
-            <a:ext cx="1572768" cy="658368"/>
+            <a:off x="7589520" y="4197096"/>
+            <a:ext cx="4023360" cy="566928"/>
           </a:xfrm>
           <a:prstGeom prst="roundRect">
             <a:avLst>
@@ -13719,57 +13764,14 @@
       </p:sp>
       <p:sp>
         <p:nvSpPr>
-          <p:cNvPr id="17" name="TextBox 16"/>
-          <p:cNvSpPr txBox="1"/>
-          <p:nvPr/>
-        </p:nvSpPr>
-        <p:spPr>
-          <a:xfrm>
-            <a:off x="8028431" y="2578608"/>
-            <a:ext cx="1572768" cy="530352"/>
-          </a:xfrm>
-          <a:prstGeom prst="rect">
-            <a:avLst/>
-          </a:prstGeom>
-          <a:noFill/>
-        </p:spPr>
-        <p:txBody>
-          <a:bodyPr wrap="square" anchor="t"/>
-          <a:lstStyle/>
-          <a:p>
-            <a:pPr algn="ctr">
-              <a:lnSpc>
-                <a:spcPct val="100000"/>
-              </a:lnSpc>
-              <a:spcBef>
-                <a:spcPts val="0"/>
-              </a:spcBef>
-              <a:spcAft>
-                <a:spcPts val="200"/>
-              </a:spcAft>
-              <a:defRPr sz="1000" b="1" i="0">
-                <a:solidFill>
-                  <a:srgbClr val="FFFFFF"/>
-                </a:solidFill>
-                <a:latin typeface="Calibri"/>
-              </a:defRPr>
-            </a:pPr>
-            <a:r>
-              <a:t>5. Solve</a:t>
-            </a:r>
-          </a:p>
-        </p:txBody>
-      </p:sp>
-      <p:sp>
-        <p:nvSpPr>
           <p:cNvPr id="18" name="TextBox 17"/>
           <p:cNvSpPr txBox="1"/>
           <p:nvPr/>
         </p:nvSpPr>
         <p:spPr>
           <a:xfrm>
-            <a:off x="9610344" y="2578608"/>
-            <a:ext cx="219456" cy="530352"/>
+            <a:off x="7589520" y="4242816"/>
+            <a:ext cx="4023360" cy="475488"/>
           </a:xfrm>
           <a:prstGeom prst="rect">
             <a:avLst/>
@@ -13777,10 +13779,10 @@
           <a:noFill/>
         </p:spPr>
         <p:txBody>
-          <a:bodyPr wrap="square" anchor="t"/>
-          <a:lstStyle/>
-          <a:p>
-            <a:pPr algn="ctr">
+          <a:bodyPr wrap="square" lIns="274320"/>
+          <a:lstStyle/>
+          <a:p>
+            <a:pPr algn="l">
               <a:lnSpc>
                 <a:spcPct val="100000"/>
               </a:lnSpc>
@@ -13790,15 +13792,15 @@
               <a:spcAft>
                 <a:spcPts val="200"/>
               </a:spcAft>
-              <a:defRPr sz="2000" b="1" i="0">
-                <a:solidFill>
-                  <a:srgbClr val="0B5B55"/>
-                </a:solidFill>
-                <a:latin typeface="Calibri"/>
-              </a:defRPr>
-            </a:pPr>
-            <a:r>
-              <a:t>›</a:t>
+              <a:defRPr sz="1200" b="1" i="0">
+                <a:solidFill>
+                  <a:srgbClr val="FFFFFF"/>
+                </a:solidFill>
+                <a:latin typeface="Calibri"/>
+              </a:defRPr>
+            </a:pPr>
+            <a:r>
+              <a:t>5. Solve</a:t>
             </a:r>
           </a:p>
         </p:txBody>
@@ -13811,8 +13813,8 @@
         </p:nvSpPr>
         <p:spPr>
           <a:xfrm>
-            <a:off x="9829800" y="2514600"/>
-            <a:ext cx="1572768" cy="658368"/>
+            <a:off x="7589520" y="4892040"/>
+            <a:ext cx="4023360" cy="566928"/>
           </a:xfrm>
           <a:prstGeom prst="roundRect">
             <a:avLst>
@@ -13857,8 +13859,8 @@
         </p:nvSpPr>
         <p:spPr>
           <a:xfrm>
-            <a:off x="9829800" y="2578608"/>
-            <a:ext cx="1572768" cy="530352"/>
+            <a:off x="7589520" y="4937759"/>
+            <a:ext cx="4023360" cy="475488"/>
           </a:xfrm>
           <a:prstGeom prst="rect">
             <a:avLst/>
@@ -13866,10 +13868,10 @@
           <a:noFill/>
         </p:spPr>
         <p:txBody>
-          <a:bodyPr wrap="square" anchor="t"/>
-          <a:lstStyle/>
-          <a:p>
-            <a:pPr algn="ctr">
+          <a:bodyPr wrap="square" lIns="274320"/>
+          <a:lstStyle/>
+          <a:p>
+            <a:pPr algn="l">
               <a:lnSpc>
                 <a:spcPct val="100000"/>
               </a:lnSpc>
@@ -13879,7 +13881,7 @@
               <a:spcAft>
                 <a:spcPts val="200"/>
               </a:spcAft>
-              <a:defRPr sz="1000" b="1" i="0">
+              <a:defRPr sz="1200" b="1" i="0">
                 <a:solidFill>
                   <a:srgbClr val="FFFFFF"/>
                 </a:solidFill>
@@ -13888,227 +13890,6 @@
             </a:pPr>
             <a:r>
               <a:t>6. Follow up</a:t>
-            </a:r>
-          </a:p>
-        </p:txBody>
-      </p:sp>
-      <p:sp>
-        <p:nvSpPr>
-          <p:cNvPr id="21" name="TextBox 20"/>
-          <p:cNvSpPr txBox="1"/>
-          <p:nvPr/>
-        </p:nvSpPr>
-        <p:spPr>
-          <a:xfrm>
-            <a:off x="548640" y="3429000"/>
-            <a:ext cx="11091672" cy="457200"/>
-          </a:xfrm>
-          <a:prstGeom prst="rect">
-            <a:avLst/>
-          </a:prstGeom>
-          <a:noFill/>
-        </p:spPr>
-        <p:txBody>
-          <a:bodyPr wrap="square" anchor="t"/>
-          <a:lstStyle/>
-          <a:p>
-            <a:pPr algn="ctr">
-              <a:lnSpc>
-                <a:spcPct val="100000"/>
-              </a:lnSpc>
-              <a:spcBef>
-                <a:spcPts val="0"/>
-              </a:spcBef>
-              <a:spcAft>
-                <a:spcPts val="200"/>
-              </a:spcAft>
-              <a:defRPr sz="1100" b="0" i="0">
-                <a:solidFill>
-                  <a:srgbClr val="3D475C"/>
-                </a:solidFill>
-                <a:latin typeface="Calibri"/>
-              </a:defRPr>
-            </a:pPr>
-            <a:r>
-              <a:rPr sz="1100" b="1">
-                <a:solidFill>
-                  <a:srgbClr val="3D475C"/>
-                </a:solidFill>
-                <a:latin typeface="Calibri"/>
-              </a:rPr>
-              <a:t>01 Clarify  ·  </a:t>
-            </a:r>
-            <a:r>
-              <a:rPr sz="1100" b="1">
-                <a:solidFill>
-                  <a:srgbClr val="3D475C"/>
-                </a:solidFill>
-                <a:latin typeface="Calibri"/>
-              </a:rPr>
-              <a:t>02 Empathize  ·  </a:t>
-            </a:r>
-            <a:r>
-              <a:rPr sz="1100" b="1">
-                <a:solidFill>
-                  <a:srgbClr val="3D475C"/>
-                </a:solidFill>
-                <a:latin typeface="Calibri"/>
-              </a:rPr>
-              <a:t>03 Bound  ·  </a:t>
-            </a:r>
-            <a:r>
-              <a:rPr sz="1100" b="1">
-                <a:solidFill>
-                  <a:srgbClr val="3D475C"/>
-                </a:solidFill>
-                <a:latin typeface="Calibri"/>
-              </a:rPr>
-              <a:t>04 Diagnose  ·  </a:t>
-            </a:r>
-            <a:r>
-              <a:rPr sz="1100" b="1">
-                <a:solidFill>
-                  <a:srgbClr val="3D475C"/>
-                </a:solidFill>
-                <a:latin typeface="Calibri"/>
-              </a:rPr>
-              <a:t>05 Evidence</a:t>
-            </a:r>
-          </a:p>
-        </p:txBody>
-      </p:sp>
-      <p:sp>
-        <p:nvSpPr>
-          <p:cNvPr id="22" name="TextBox 21"/>
-          <p:cNvSpPr txBox="1"/>
-          <p:nvPr/>
-        </p:nvSpPr>
-        <p:spPr>
-          <a:xfrm>
-            <a:off x="1463040" y="4160520"/>
-            <a:ext cx="9262872" cy="1005840"/>
-          </a:xfrm>
-          <a:prstGeom prst="rect">
-            <a:avLst/>
-          </a:prstGeom>
-          <a:noFill/>
-        </p:spPr>
-        <p:txBody>
-          <a:bodyPr wrap="square" anchor="t"/>
-          <a:lstStyle/>
-          <a:p>
-            <a:pPr algn="ctr">
-              <a:lnSpc>
-                <a:spcPct val="100000"/>
-              </a:lnSpc>
-              <a:spcBef>
-                <a:spcPts val="0"/>
-              </a:spcBef>
-              <a:spcAft>
-                <a:spcPts val="200"/>
-              </a:spcAft>
-              <a:defRPr sz="2000" b="0" i="1">
-                <a:solidFill>
-                  <a:srgbClr val="0B5B55"/>
-                </a:solidFill>
-                <a:latin typeface="Calibri"/>
-              </a:defRPr>
-            </a:pPr>
-            <a:r>
-              <a:t>You can’t control the client’s temperature —</a:t>
-            </a:r>
-            <a:br/>
-            <a:r>
-              <a:t>but you always control your own.</a:t>
-            </a:r>
-          </a:p>
-        </p:txBody>
-      </p:sp>
-      <p:sp>
-        <p:nvSpPr>
-          <p:cNvPr id="23" name="Rounded Rectangle 22"/>
-          <p:cNvSpPr/>
-          <p:nvPr/>
-        </p:nvSpPr>
-        <p:spPr>
-          <a:xfrm>
-            <a:off x="4956048" y="5349240"/>
-            <a:ext cx="2286000" cy="566928"/>
-          </a:xfrm>
-          <a:prstGeom prst="roundRect">
-            <a:avLst>
-              <a:gd name="adj" fmla="val 50000"/>
-            </a:avLst>
-          </a:prstGeom>
-          <a:solidFill>
-            <a:srgbClr val="0F766E"/>
-          </a:solidFill>
-          <a:ln>
-            <a:noFill/>
-          </a:ln>
-          <a:effectLst/>
-        </p:spPr>
-        <p:style>
-          <a:lnRef idx="1">
-            <a:schemeClr val="accent1"/>
-          </a:lnRef>
-          <a:fillRef idx="3">
-            <a:schemeClr val="accent1"/>
-          </a:fillRef>
-          <a:effectRef idx="2">
-            <a:schemeClr val="accent1"/>
-          </a:effectRef>
-          <a:fontRef idx="minor">
-            <a:schemeClr val="lt1"/>
-          </a:fontRef>
-        </p:style>
-        <p:txBody>
-          <a:bodyPr rtlCol="0" anchor="ctr"/>
-          <a:lstStyle/>
-          <a:p>
-            <a:pPr algn="ctr"/>
-          </a:p>
-        </p:txBody>
-      </p:sp>
-      <p:sp>
-        <p:nvSpPr>
-          <p:cNvPr id="24" name="TextBox 23"/>
-          <p:cNvSpPr txBox="1"/>
-          <p:nvPr/>
-        </p:nvSpPr>
-        <p:spPr>
-          <a:xfrm>
-            <a:off x="4956048" y="5394960"/>
-            <a:ext cx="2286000" cy="475488"/>
-          </a:xfrm>
-          <a:prstGeom prst="rect">
-            <a:avLst/>
-          </a:prstGeom>
-          <a:noFill/>
-        </p:spPr>
-        <p:txBody>
-          <a:bodyPr wrap="square" anchor="t"/>
-          <a:lstStyle/>
-          <a:p>
-            <a:pPr algn="ctr">
-              <a:lnSpc>
-                <a:spcPct val="100000"/>
-              </a:lnSpc>
-              <a:spcBef>
-                <a:spcPts val="0"/>
-              </a:spcBef>
-              <a:spcAft>
-                <a:spcPts val="200"/>
-              </a:spcAft>
-              <a:defRPr sz="1300" b="1" i="0">
-                <a:solidFill>
-                  <a:srgbClr val="FFFFFF"/>
-                </a:solidFill>
-                <a:latin typeface="Calibri"/>
-              </a:defRPr>
-            </a:pPr>
-            <a:r>
-              <a:t>Thank you  ·  Q&amp;A</a:t>
             </a:r>
           </a:p>
         </p:txBody>

</xml_diff>

<commit_message>
Reorder slide 2 numbering
Co-authored-by: Copilot <223556219+Copilot@users.noreply.github.com>
</commit_message>
<xml_diff>
--- a/Difficult_Clients_Behaviors_Final.pptx
+++ b/Difficult_Clients_Behaviors_Final.pptx
@@ -5611,7 +5611,7 @@
         </p:nvSpPr>
         <p:spPr>
           <a:xfrm>
-            <a:off x="3653028" y="2948940"/>
+            <a:off x="5682996" y="2948940"/>
             <a:ext cx="960120" cy="960120"/>
           </a:xfrm>
           <a:prstGeom prst="ellipse">
@@ -5663,7 +5663,7 @@
         </p:blipFill>
         <p:spPr>
           <a:xfrm>
-            <a:off x="3845052" y="3140964"/>
+            <a:off x="5875020" y="3140964"/>
             <a:ext cx="576072" cy="576072"/>
           </a:xfrm>
           <a:prstGeom prst="rect">
@@ -5679,7 +5679,7 @@
         </p:nvSpPr>
         <p:spPr>
           <a:xfrm>
-            <a:off x="3264408" y="4005072"/>
+            <a:off x="5294376" y="4005072"/>
             <a:ext cx="1737360" cy="1143000"/>
           </a:xfrm>
           <a:prstGeom prst="rect">
@@ -5766,7 +5766,7 @@
         </p:nvSpPr>
         <p:spPr>
           <a:xfrm>
-            <a:off x="4069080" y="2715768"/>
+            <a:off x="6099048" y="2715768"/>
             <a:ext cx="146304" cy="146304"/>
           </a:xfrm>
           <a:prstGeom prst="ellipse">
@@ -5810,7 +5810,7 @@
         </p:nvSpPr>
         <p:spPr>
           <a:xfrm>
-            <a:off x="5682996" y="2948940"/>
+            <a:off x="3653028" y="2948940"/>
             <a:ext cx="960120" cy="960120"/>
           </a:xfrm>
           <a:prstGeom prst="ellipse">
@@ -5862,7 +5862,7 @@
         </p:blipFill>
         <p:spPr>
           <a:xfrm>
-            <a:off x="5875020" y="3140964"/>
+            <a:off x="3845052" y="3140964"/>
             <a:ext cx="576072" cy="576072"/>
           </a:xfrm>
           <a:prstGeom prst="rect">
@@ -5878,7 +5878,7 @@
         </p:nvSpPr>
         <p:spPr>
           <a:xfrm>
-            <a:off x="5294376" y="4005072"/>
+            <a:off x="3264408" y="4005072"/>
             <a:ext cx="1737360" cy="1143000"/>
           </a:xfrm>
           <a:prstGeom prst="rect">
@@ -5965,7 +5965,7 @@
         </p:nvSpPr>
         <p:spPr>
           <a:xfrm>
-            <a:off x="6099048" y="2715768"/>
+            <a:off x="4069080" y="2715768"/>
             <a:ext cx="146304" cy="146304"/>
           </a:xfrm>
           <a:prstGeom prst="ellipse">
@@ -6539,7 +6539,7 @@
         </p:nvSpPr>
         <p:spPr>
           <a:xfrm>
-            <a:off x="3273552" y="5230368"/>
+            <a:off x="5084064" y="5230368"/>
             <a:ext cx="1600200" cy="457200"/>
           </a:xfrm>
           <a:prstGeom prst="roundRect">
@@ -6585,7 +6585,7 @@
         </p:nvSpPr>
         <p:spPr>
           <a:xfrm>
-            <a:off x="3273552" y="5266944"/>
+            <a:off x="5084064" y="5266944"/>
             <a:ext cx="1600200" cy="384048"/>
           </a:xfrm>
           <a:prstGeom prst="rect">
@@ -6628,7 +6628,7 @@
         </p:nvSpPr>
         <p:spPr>
           <a:xfrm>
-            <a:off x="5084064" y="5230368"/>
+            <a:off x="3273552" y="5230368"/>
             <a:ext cx="1600200" cy="457200"/>
           </a:xfrm>
           <a:prstGeom prst="roundRect">
@@ -6674,7 +6674,7 @@
         </p:nvSpPr>
         <p:spPr>
           <a:xfrm>
-            <a:off x="5084064" y="5266944"/>
+            <a:off x="3273552" y="5266944"/>
             <a:ext cx="1600200" cy="384048"/>
           </a:xfrm>
           <a:prstGeom prst="rect">

</xml_diff>

<commit_message>
Fix slide 1 card alignment
Remove placeholder fields and expand the behavior cards so labels fit alongside their icons.\n\nCo-authored-by: Copilot <223556219+Copilot@users.noreply.github.com>
</commit_message>
<xml_diff>
--- a/Difficult_Clients_Behaviors_Final.pptx
+++ b/Difficult_Clients_Behaviors_Final.pptx
@@ -4074,196 +4074,14 @@
       </p:sp>
       <p:sp>
         <p:nvSpPr>
-          <p:cNvPr id="5" name="Rounded Rectangle 4"/>
-          <p:cNvSpPr/>
-          <p:nvPr/>
-        </p:nvSpPr>
-        <p:spPr>
-          <a:xfrm>
-            <a:off x="640080" y="3154680"/>
-            <a:ext cx="3291840" cy="502920"/>
-          </a:xfrm>
-          <a:prstGeom prst="roundRect">
-            <a:avLst>
-              <a:gd name="adj" fmla="val 18000"/>
-            </a:avLst>
-          </a:prstGeom>
-          <a:solidFill>
-            <a:srgbClr val="FFFFFF"/>
-          </a:solidFill>
-          <a:ln w="12700">
-            <a:solidFill>
-              <a:srgbClr val="DDD6C7"/>
-            </a:solidFill>
-          </a:ln>
-          <a:effectLst/>
-        </p:spPr>
-        <p:style>
-          <a:lnRef idx="1">
-            <a:schemeClr val="accent1"/>
-          </a:lnRef>
-          <a:fillRef idx="3">
-            <a:schemeClr val="accent1"/>
-          </a:fillRef>
-          <a:effectRef idx="2">
-            <a:schemeClr val="accent1"/>
-          </a:effectRef>
-          <a:fontRef idx="minor">
-            <a:schemeClr val="lt1"/>
-          </a:fontRef>
-        </p:style>
-        <p:txBody>
-          <a:bodyPr rtlCol="0" anchor="ctr"/>
-          <a:lstStyle/>
-          <a:p>
-            <a:pPr algn="ctr"/>
-          </a:p>
-        </p:txBody>
-      </p:sp>
-      <p:sp>
-        <p:nvSpPr>
-          <p:cNvPr id="6" name="TextBox 5"/>
-          <p:cNvSpPr txBox="1"/>
-          <p:nvPr/>
-        </p:nvSpPr>
-        <p:spPr>
-          <a:xfrm>
-            <a:off x="822960" y="3218688"/>
-            <a:ext cx="2926080" cy="411480"/>
-          </a:xfrm>
-          <a:prstGeom prst="rect">
-            <a:avLst/>
-          </a:prstGeom>
-          <a:noFill/>
-        </p:spPr>
-        <p:txBody>
-          <a:bodyPr wrap="square"/>
-          <a:lstStyle/>
-          <a:p>
-            <a:pPr algn="l">
-              <a:lnSpc>
-                <a:spcPct val="100000"/>
-              </a:lnSpc>
-              <a:spcBef>
-                <a:spcPts val="0"/>
-              </a:spcBef>
-              <a:spcAft>
-                <a:spcPts val="200"/>
-              </a:spcAft>
-              <a:defRPr sz="1200" b="0" i="0">
-                <a:solidFill>
-                  <a:srgbClr val="3D475C"/>
-                </a:solidFill>
-                <a:latin typeface="Calibri"/>
-              </a:defRPr>
-            </a:pPr>
-            <a:r>
-              <a:t>[ Your Name ]</a:t>
-            </a:r>
-          </a:p>
-        </p:txBody>
-      </p:sp>
-      <p:sp>
-        <p:nvSpPr>
-          <p:cNvPr id="7" name="Rounded Rectangle 6"/>
-          <p:cNvSpPr/>
-          <p:nvPr/>
-        </p:nvSpPr>
-        <p:spPr>
-          <a:xfrm>
-            <a:off x="4114800" y="3154680"/>
-            <a:ext cx="3291840" cy="502920"/>
-          </a:xfrm>
-          <a:prstGeom prst="roundRect">
-            <a:avLst>
-              <a:gd name="adj" fmla="val 18000"/>
-            </a:avLst>
-          </a:prstGeom>
-          <a:solidFill>
-            <a:srgbClr val="FFFFFF"/>
-          </a:solidFill>
-          <a:ln w="12700">
-            <a:solidFill>
-              <a:srgbClr val="DDD6C7"/>
-            </a:solidFill>
-          </a:ln>
-          <a:effectLst/>
-        </p:spPr>
-        <p:style>
-          <a:lnRef idx="1">
-            <a:schemeClr val="accent1"/>
-          </a:lnRef>
-          <a:fillRef idx="3">
-            <a:schemeClr val="accent1"/>
-          </a:fillRef>
-          <a:effectRef idx="2">
-            <a:schemeClr val="accent1"/>
-          </a:effectRef>
-          <a:fontRef idx="minor">
-            <a:schemeClr val="lt1"/>
-          </a:fontRef>
-        </p:style>
-        <p:txBody>
-          <a:bodyPr rtlCol="0" anchor="ctr"/>
-          <a:lstStyle/>
-          <a:p>
-            <a:pPr algn="ctr"/>
-          </a:p>
-        </p:txBody>
-      </p:sp>
-      <p:sp>
-        <p:nvSpPr>
-          <p:cNvPr id="8" name="TextBox 7"/>
-          <p:cNvSpPr txBox="1"/>
-          <p:nvPr/>
-        </p:nvSpPr>
-        <p:spPr>
-          <a:xfrm>
-            <a:off x="4297680" y="3218688"/>
-            <a:ext cx="2926080" cy="411480"/>
-          </a:xfrm>
-          <a:prstGeom prst="rect">
-            <a:avLst/>
-          </a:prstGeom>
-          <a:noFill/>
-        </p:spPr>
-        <p:txBody>
-          <a:bodyPr wrap="square"/>
-          <a:lstStyle/>
-          <a:p>
-            <a:pPr algn="l">
-              <a:lnSpc>
-                <a:spcPct val="100000"/>
-              </a:lnSpc>
-              <a:spcBef>
-                <a:spcPts val="0"/>
-              </a:spcBef>
-              <a:spcAft>
-                <a:spcPts val="200"/>
-              </a:spcAft>
-              <a:defRPr sz="1200" b="0" i="0">
-                <a:solidFill>
-                  <a:srgbClr val="3D475C"/>
-                </a:solidFill>
-                <a:latin typeface="Calibri"/>
-              </a:defRPr>
-            </a:pPr>
-            <a:r>
-              <a:t>[ Course / Section ]</a:t>
-            </a:r>
-          </a:p>
-        </p:txBody>
-      </p:sp>
-      <p:sp>
-        <p:nvSpPr>
           <p:cNvPr id="9" name="Rounded Rectangle 8"/>
           <p:cNvSpPr/>
           <p:nvPr/>
         </p:nvSpPr>
         <p:spPr>
           <a:xfrm>
-            <a:off x="566928" y="4069080"/>
-            <a:ext cx="1316736" cy="868680"/>
+            <a:off x="548640" y="3886200"/>
+            <a:ext cx="2148840" cy="1051560"/>
           </a:xfrm>
           <a:prstGeom prst="roundRect">
             <a:avLst>
@@ -4318,7 +4136,7 @@
         </p:blipFill>
         <p:spPr>
           <a:xfrm>
-            <a:off x="786384" y="4224528"/>
+            <a:off x="685800" y="4137660"/>
             <a:ext cx="548640" cy="548640"/>
           </a:xfrm>
           <a:prstGeom prst="rect">
@@ -4334,8 +4152,8 @@
         </p:nvSpPr>
         <p:spPr>
           <a:xfrm>
-            <a:off x="1371600" y="4133087"/>
-            <a:ext cx="1316736" cy="749808"/>
+            <a:off x="1289304" y="4023360"/>
+            <a:ext cx="1371600" cy="777240"/>
           </a:xfrm>
           <a:prstGeom prst="rect">
             <a:avLst/>
@@ -4399,8 +4217,8 @@
         </p:nvSpPr>
         <p:spPr>
           <a:xfrm>
-            <a:off x="2779776" y="4069080"/>
-            <a:ext cx="1316736" cy="868680"/>
+            <a:off x="2788920" y="3886200"/>
+            <a:ext cx="2148840" cy="1051560"/>
           </a:xfrm>
           <a:prstGeom prst="roundRect">
             <a:avLst>
@@ -4455,7 +4273,7 @@
         </p:blipFill>
         <p:spPr>
           <a:xfrm>
-            <a:off x="2999232" y="4224528"/>
+            <a:off x="2926080" y="4137660"/>
             <a:ext cx="548640" cy="548640"/>
           </a:xfrm>
           <a:prstGeom prst="rect">
@@ -4471,8 +4289,8 @@
         </p:nvSpPr>
         <p:spPr>
           <a:xfrm>
-            <a:off x="3584448" y="4133087"/>
-            <a:ext cx="1316736" cy="749808"/>
+            <a:off x="3529584" y="4023360"/>
+            <a:ext cx="1371600" cy="777240"/>
           </a:xfrm>
           <a:prstGeom prst="rect">
             <a:avLst/>
@@ -4536,8 +4354,8 @@
         </p:nvSpPr>
         <p:spPr>
           <a:xfrm>
-            <a:off x="4992624" y="4069080"/>
-            <a:ext cx="1316736" cy="868680"/>
+            <a:off x="5029200" y="3886200"/>
+            <a:ext cx="2148840" cy="1051560"/>
           </a:xfrm>
           <a:prstGeom prst="roundRect">
             <a:avLst>
@@ -4592,7 +4410,7 @@
         </p:blipFill>
         <p:spPr>
           <a:xfrm>
-            <a:off x="5212080" y="4224528"/>
+            <a:off x="5166360" y="4137660"/>
             <a:ext cx="548640" cy="548640"/>
           </a:xfrm>
           <a:prstGeom prst="rect">
@@ -4608,8 +4426,8 @@
         </p:nvSpPr>
         <p:spPr>
           <a:xfrm>
-            <a:off x="5797296" y="4133087"/>
-            <a:ext cx="1316736" cy="749808"/>
+            <a:off x="5769864" y="4023360"/>
+            <a:ext cx="1371600" cy="777240"/>
           </a:xfrm>
           <a:prstGeom prst="rect">
             <a:avLst/>
@@ -4673,8 +4491,8 @@
         </p:nvSpPr>
         <p:spPr>
           <a:xfrm>
-            <a:off x="7205472" y="4069080"/>
-            <a:ext cx="1316736" cy="868680"/>
+            <a:off x="7269480" y="3886200"/>
+            <a:ext cx="2148840" cy="1051560"/>
           </a:xfrm>
           <a:prstGeom prst="roundRect">
             <a:avLst>
@@ -4729,7 +4547,7 @@
         </p:blipFill>
         <p:spPr>
           <a:xfrm>
-            <a:off x="7424927" y="4224528"/>
+            <a:off x="7406640" y="4137660"/>
             <a:ext cx="548640" cy="548640"/>
           </a:xfrm>
           <a:prstGeom prst="rect">
@@ -4745,8 +4563,8 @@
         </p:nvSpPr>
         <p:spPr>
           <a:xfrm>
-            <a:off x="8010144" y="4133087"/>
-            <a:ext cx="1316736" cy="749808"/>
+            <a:off x="8010144" y="4023360"/>
+            <a:ext cx="1371600" cy="777240"/>
           </a:xfrm>
           <a:prstGeom prst="rect">
             <a:avLst/>
@@ -4810,8 +4628,8 @@
         </p:nvSpPr>
         <p:spPr>
           <a:xfrm>
-            <a:off x="9418320" y="4069080"/>
-            <a:ext cx="1316736" cy="868680"/>
+            <a:off x="9509760" y="3886200"/>
+            <a:ext cx="2148840" cy="1051560"/>
           </a:xfrm>
           <a:prstGeom prst="roundRect">
             <a:avLst>
@@ -4866,7 +4684,7 @@
         </p:blipFill>
         <p:spPr>
           <a:xfrm>
-            <a:off x="9637776" y="4224528"/>
+            <a:off x="9646920" y="4137660"/>
             <a:ext cx="548640" cy="548640"/>
           </a:xfrm>
           <a:prstGeom prst="rect">
@@ -4882,8 +4700,8 @@
         </p:nvSpPr>
         <p:spPr>
           <a:xfrm>
-            <a:off x="10222992" y="4133087"/>
-            <a:ext cx="1316736" cy="749808"/>
+            <a:off x="10250424" y="4023360"/>
+            <a:ext cx="1371600" cy="777240"/>
           </a:xfrm>
           <a:prstGeom prst="rect">
             <a:avLst/>

</xml_diff>